<commit_message>
Update presentation and tableau workbook, remove lock files
</commit_message>
<xml_diff>
--- a/results/capstone_presentation_v09.pptx
+++ b/results/capstone_presentation_v09.pptx
@@ -225,7 +225,7 @@
           <a:p>
             <a:fld id="{01316F3D-AFAA-47CB-BB97-3BC1CCDC8235}" type="datetimeFigureOut">
               <a:rPr lang="de-AT" smtClean="0"/>
-              <a:t>23.10.2025</a:t>
+              <a:t>27.10.2025</a:t>
             </a:fld>
             <a:endParaRPr lang="de-AT"/>
           </a:p>
@@ -13096,7 +13096,7 @@
           <a:p>
             <a:fld id="{5BCAD085-E8A6-8845-BD4E-CB4CCA059FC4}" type="datetimeFigureOut">
               <a:rPr lang="en-US" smtClean="0"/>
-              <a:t>10/23/2025</a:t>
+              <a:t>10/27/2025</a:t>
             </a:fld>
             <a:endParaRPr lang="en-US"/>
           </a:p>
@@ -13264,7 +13264,7 @@
           <a:p>
             <a:fld id="{5BCAD085-E8A6-8845-BD4E-CB4CCA059FC4}" type="datetimeFigureOut">
               <a:rPr lang="en-US" smtClean="0"/>
-              <a:t>10/23/2025</a:t>
+              <a:t>10/27/2025</a:t>
             </a:fld>
             <a:endParaRPr lang="en-US"/>
           </a:p>
@@ -13442,7 +13442,7 @@
           <a:p>
             <a:fld id="{5BCAD085-E8A6-8845-BD4E-CB4CCA059FC4}" type="datetimeFigureOut">
               <a:rPr lang="en-US" smtClean="0"/>
-              <a:t>10/23/2025</a:t>
+              <a:t>10/27/2025</a:t>
             </a:fld>
             <a:endParaRPr lang="en-US"/>
           </a:p>
@@ -13610,7 +13610,7 @@
           <a:p>
             <a:fld id="{5BCAD085-E8A6-8845-BD4E-CB4CCA059FC4}" type="datetimeFigureOut">
               <a:rPr lang="en-US" smtClean="0"/>
-              <a:t>10/23/2025</a:t>
+              <a:t>10/27/2025</a:t>
             </a:fld>
             <a:endParaRPr lang="en-US"/>
           </a:p>
@@ -13855,7 +13855,7 @@
           <a:p>
             <a:fld id="{5BCAD085-E8A6-8845-BD4E-CB4CCA059FC4}" type="datetimeFigureOut">
               <a:rPr lang="en-US" smtClean="0"/>
-              <a:t>10/23/2025</a:t>
+              <a:t>10/27/2025</a:t>
             </a:fld>
             <a:endParaRPr lang="en-US"/>
           </a:p>
@@ -14140,7 +14140,7 @@
           <a:p>
             <a:fld id="{5BCAD085-E8A6-8845-BD4E-CB4CCA059FC4}" type="datetimeFigureOut">
               <a:rPr lang="en-US" smtClean="0"/>
-              <a:t>10/23/2025</a:t>
+              <a:t>10/27/2025</a:t>
             </a:fld>
             <a:endParaRPr lang="en-US"/>
           </a:p>
@@ -14559,7 +14559,7 @@
           <a:p>
             <a:fld id="{5BCAD085-E8A6-8845-BD4E-CB4CCA059FC4}" type="datetimeFigureOut">
               <a:rPr lang="en-US" smtClean="0"/>
-              <a:t>10/23/2025</a:t>
+              <a:t>10/27/2025</a:t>
             </a:fld>
             <a:endParaRPr lang="en-US"/>
           </a:p>
@@ -14676,7 +14676,7 @@
           <a:p>
             <a:fld id="{5BCAD085-E8A6-8845-BD4E-CB4CCA059FC4}" type="datetimeFigureOut">
               <a:rPr lang="en-US" smtClean="0"/>
-              <a:t>10/23/2025</a:t>
+              <a:t>10/27/2025</a:t>
             </a:fld>
             <a:endParaRPr lang="en-US"/>
           </a:p>
@@ -14771,7 +14771,7 @@
           <a:p>
             <a:fld id="{5BCAD085-E8A6-8845-BD4E-CB4CCA059FC4}" type="datetimeFigureOut">
               <a:rPr lang="en-US" smtClean="0"/>
-              <a:t>10/23/2025</a:t>
+              <a:t>10/27/2025</a:t>
             </a:fld>
             <a:endParaRPr lang="en-US"/>
           </a:p>
@@ -15046,7 +15046,7 @@
           <a:p>
             <a:fld id="{5BCAD085-E8A6-8845-BD4E-CB4CCA059FC4}" type="datetimeFigureOut">
               <a:rPr lang="en-US" smtClean="0"/>
-              <a:t>10/23/2025</a:t>
+              <a:t>10/27/2025</a:t>
             </a:fld>
             <a:endParaRPr lang="en-US"/>
           </a:p>
@@ -15298,7 +15298,7 @@
           <a:p>
             <a:fld id="{5BCAD085-E8A6-8845-BD4E-CB4CCA059FC4}" type="datetimeFigureOut">
               <a:rPr lang="en-US" smtClean="0"/>
-              <a:t>10/23/2025</a:t>
+              <a:t>10/27/2025</a:t>
             </a:fld>
             <a:endParaRPr lang="en-US"/>
           </a:p>
@@ -15509,7 +15509,7 @@
           <a:p>
             <a:fld id="{5BCAD085-E8A6-8845-BD4E-CB4CCA059FC4}" type="datetimeFigureOut">
               <a:rPr lang="en-US" smtClean="0"/>
-              <a:t>10/23/2025</a:t>
+              <a:t>10/27/2025</a:t>
             </a:fld>
             <a:endParaRPr lang="en-US"/>
           </a:p>
@@ -17960,7 +17960,7 @@
 </file>
 
 <file path=ppt/slides/slide13.xml><?xml version="1.0" encoding="utf-8"?>
-<p:sld xmlns:a="http://schemas.openxmlformats.org/drawingml/2006/main" xmlns:r="http://schemas.openxmlformats.org/officeDocument/2006/relationships" xmlns:p="http://schemas.openxmlformats.org/presentationml/2006/main">
+<p:sld xmlns:a="http://schemas.openxmlformats.org/drawingml/2006/main" xmlns:r="http://schemas.openxmlformats.org/officeDocument/2006/relationships" xmlns:p="http://schemas.openxmlformats.org/presentationml/2006/main" show="0">
   <p:cSld>
     <p:spTree>
       <p:nvGrpSpPr>

</xml_diff>